<commit_message>
Updates after June meeting.
</commit_message>
<xml_diff>
--- a/Subgroups/ASX/Status Reporting/2026-06 ASX Status Update.pptx
+++ b/Subgroups/ASX/Status Reporting/2026-06 ASX Status Update.pptx
@@ -6,10 +6,10 @@
     <p:sldMasterId id="2147484069" r:id="rId5"/>
   </p:sldMasterIdLst>
   <p:notesMasterIdLst>
-    <p:notesMasterId r:id="rId13"/>
+    <p:notesMasterId r:id="rId14"/>
   </p:notesMasterIdLst>
   <p:handoutMasterIdLst>
-    <p:handoutMasterId r:id="rId14"/>
+    <p:handoutMasterId r:id="rId15"/>
   </p:handoutMasterIdLst>
   <p:sldIdLst>
     <p:sldId id="2147470876" r:id="rId6"/>
@@ -18,12 +18,13 @@
     <p:sldId id="2147472439" r:id="rId9"/>
     <p:sldId id="2147472438" r:id="rId10"/>
     <p:sldId id="2147472421" r:id="rId11"/>
-    <p:sldId id="2147470948" r:id="rId12"/>
+    <p:sldId id="2147472440" r:id="rId12"/>
+    <p:sldId id="2147470948" r:id="rId13"/>
   </p:sldIdLst>
   <p:sldSz cx="12192000" cy="6858000"/>
   <p:notesSz cx="6858000" cy="9144000"/>
   <p:custDataLst>
-    <p:tags r:id="rId15"/>
+    <p:tags r:id="rId16"/>
   </p:custDataLst>
   <p:defaultTextStyle>
     <a:defPPr>
@@ -161,6 +162,7 @@
             <p14:sldId id="2147472439"/>
             <p14:sldId id="2147472438"/>
             <p14:sldId id="2147472421"/>
+            <p14:sldId id="2147472440"/>
             <p14:sldId id="2147470948"/>
           </p14:sldIdLst>
         </p14:section>
@@ -363,7 +365,7 @@
                 </a:solidFill>
                 <a:latin typeface="Red Hat Display" panose="02010303040201060303" pitchFamily="2" charset="0"/>
               </a:rPr>
-              <a:t>2026-06-10</a:t>
+              <a:t>2026-06-11</a:t>
             </a:fld>
             <a:endParaRPr lang="en-CA">
               <a:solidFill>
@@ -571,7 +573,7 @@
             <a:fld id="{862401FA-03E4-417E-850D-BECBAC0BE149}" type="datetimeFigureOut">
               <a:rPr lang="en-CA" smtClean="0"/>
               <a:pPr/>
-              <a:t>2026-06-10</a:t>
+              <a:t>2026-06-11</a:t>
             </a:fld>
             <a:endParaRPr lang="en-CA"/>
           </a:p>
@@ -1028,7 +1030,11 @@
           <a:bodyPr/>
           <a:lstStyle/>
           <a:p>
-            <a:endParaRPr lang="en-US" noProof="0"/>
+            <a:r>
+              <a:rPr lang="en-US" dirty="0"/>
+              <a:t>m</a:t>
+            </a:r>
+            <a:endParaRPr lang="en-CA" dirty="0"/>
           </a:p>
         </p:txBody>
       </p:sp>
@@ -1050,7 +1056,97 @@
             <a:fld id="{527AB645-225A-4E0C-832E-9FE495AA9FCD}" type="slidenum">
               <a:rPr lang="en-CA" smtClean="0"/>
               <a:pPr/>
-              <a:t>7</a:t>
+              <a:t>6</a:t>
+            </a:fld>
+            <a:endParaRPr lang="en-CA"/>
+          </a:p>
+        </p:txBody>
+      </p:sp>
+    </p:spTree>
+    <p:extLst>
+      <p:ext uri="{BB962C8B-B14F-4D97-AF65-F5344CB8AC3E}">
+        <p14:creationId xmlns:p14="http://schemas.microsoft.com/office/powerpoint/2010/main" val="3075313983"/>
+      </p:ext>
+    </p:extLst>
+  </p:cSld>
+  <p:clrMapOvr>
+    <a:masterClrMapping/>
+  </p:clrMapOvr>
+</p:notes>
+</file>
+
+<file path=ppt/notesSlides/notesSlide3.xml><?xml version="1.0" encoding="utf-8"?>
+<p:notes xmlns:a="http://schemas.openxmlformats.org/drawingml/2006/main" xmlns:r="http://schemas.openxmlformats.org/officeDocument/2006/relationships" xmlns:p="http://schemas.openxmlformats.org/presentationml/2006/main">
+  <p:cSld>
+    <p:spTree>
+      <p:nvGrpSpPr>
+        <p:cNvPr id="1" name=""/>
+        <p:cNvGrpSpPr/>
+        <p:nvPr/>
+      </p:nvGrpSpPr>
+      <p:grpSpPr>
+        <a:xfrm>
+          <a:off x="0" y="0"/>
+          <a:ext cx="0" cy="0"/>
+          <a:chOff x="0" y="0"/>
+          <a:chExt cx="0" cy="0"/>
+        </a:xfrm>
+      </p:grpSpPr>
+      <p:sp>
+        <p:nvSpPr>
+          <p:cNvPr id="2" name="Slide Image Placeholder 1"/>
+          <p:cNvSpPr>
+            <a:spLocks noGrp="1" noRot="1" noChangeAspect="1"/>
+          </p:cNvSpPr>
+          <p:nvPr>
+            <p:ph type="sldImg"/>
+          </p:nvPr>
+        </p:nvSpPr>
+        <p:spPr>
+          <a:xfrm>
+            <a:off x="549275" y="971550"/>
+            <a:ext cx="5759450" cy="3240088"/>
+          </a:xfrm>
+        </p:spPr>
+      </p:sp>
+      <p:sp>
+        <p:nvSpPr>
+          <p:cNvPr id="3" name="Notes Placeholder 2"/>
+          <p:cNvSpPr>
+            <a:spLocks noGrp="1"/>
+          </p:cNvSpPr>
+          <p:nvPr>
+            <p:ph type="body" idx="1"/>
+          </p:nvPr>
+        </p:nvSpPr>
+        <p:spPr/>
+        <p:txBody>
+          <a:bodyPr/>
+          <a:lstStyle/>
+          <a:p>
+            <a:endParaRPr lang="en-US" noProof="0"/>
+          </a:p>
+        </p:txBody>
+      </p:sp>
+      <p:sp>
+        <p:nvSpPr>
+          <p:cNvPr id="4" name="Slide Number Placeholder 3"/>
+          <p:cNvSpPr>
+            <a:spLocks noGrp="1"/>
+          </p:cNvSpPr>
+          <p:nvPr>
+            <p:ph type="sldNum" sz="quarter" idx="5"/>
+          </p:nvPr>
+        </p:nvSpPr>
+        <p:spPr/>
+        <p:txBody>
+          <a:bodyPr/>
+          <a:lstStyle/>
+          <a:p>
+            <a:fld id="{527AB645-225A-4E0C-832E-9FE495AA9FCD}" type="slidenum">
+              <a:rPr lang="en-CA" smtClean="0"/>
+              <a:pPr/>
+              <a:t>8</a:t>
             </a:fld>
             <a:endParaRPr lang="en-CA"/>
           </a:p>
@@ -1541,7 +1637,7 @@
           <a:p>
             <a:fld id="{A99DE38A-F523-4625-AD04-A26CD6F4D124}" type="datetimeFigureOut">
               <a:rPr lang="en-CA" smtClean="0"/>
-              <a:t>2026-06-10</a:t>
+              <a:t>2026-06-11</a:t>
             </a:fld>
             <a:endParaRPr lang="en-CA"/>
           </a:p>
@@ -1854,7 +1950,7 @@
           <a:p>
             <a:fld id="{A99DE38A-F523-4625-AD04-A26CD6F4D124}" type="datetimeFigureOut">
               <a:rPr lang="en-CA" smtClean="0"/>
-              <a:t>2026-06-10</a:t>
+              <a:t>2026-06-11</a:t>
             </a:fld>
             <a:endParaRPr lang="en-CA"/>
           </a:p>
@@ -2078,7 +2174,7 @@
           <a:p>
             <a:fld id="{A99DE38A-F523-4625-AD04-A26CD6F4D124}" type="datetimeFigureOut">
               <a:rPr lang="en-CA" smtClean="0"/>
-              <a:t>2026-06-10</a:t>
+              <a:t>2026-06-11</a:t>
             </a:fld>
             <a:endParaRPr lang="en-CA"/>
           </a:p>
@@ -4806,17 +4902,17 @@
           </a:ln>
           <a:extLst>
             <a:ext uri="{FAA26D3D-D897-4be2-8F04-BA451C77F1D7}">
-              <ma14:placeholderFlag xmlns:ma14="http://schemas.microsoft.com/office/mac/drawingml/2011/main" xmlns:p15="http://schemas.microsoft.com/office/powerpoint/2012/main" xmlns:p14="http://schemas.microsoft.com/office/powerpoint/2010/main" xmlns:asvg="http://schemas.microsoft.com/office/drawing/2016/SVG/main" xmlns:a16="http://schemas.microsoft.com/office/drawing/2014/main" xmlns:a14="http://schemas.microsoft.com/office/drawing/2010/main" xmlns="" val="1"/>
+              <ma14:placeholderFlag xmlns="" xmlns:a14="http://schemas.microsoft.com/office/drawing/2010/main" xmlns:a16="http://schemas.microsoft.com/office/drawing/2014/main" xmlns:asvg="http://schemas.microsoft.com/office/drawing/2016/SVG/main" xmlns:p14="http://schemas.microsoft.com/office/powerpoint/2010/main" xmlns:p15="http://schemas.microsoft.com/office/powerpoint/2012/main" xmlns:ma14="http://schemas.microsoft.com/office/mac/drawingml/2011/main" val="1"/>
             </a:ext>
             <a:ext uri="{909E8E84-426E-40dd-AFC4-6F175D3DCCD1}">
-              <a14:hiddenFill xmlns:a14="http://schemas.microsoft.com/office/drawing/2010/main" xmlns:p15="http://schemas.microsoft.com/office/powerpoint/2012/main" xmlns:p14="http://schemas.microsoft.com/office/powerpoint/2010/main" xmlns:asvg="http://schemas.microsoft.com/office/drawing/2016/SVG/main" xmlns:a16="http://schemas.microsoft.com/office/drawing/2014/main" xmlns:ma14="http://schemas.microsoft.com/office/mac/drawingml/2011/main" xmlns="">
+              <a14:hiddenFill xmlns="" xmlns:ma14="http://schemas.microsoft.com/office/mac/drawingml/2011/main" xmlns:a16="http://schemas.microsoft.com/office/drawing/2014/main" xmlns:asvg="http://schemas.microsoft.com/office/drawing/2016/SVG/main" xmlns:p14="http://schemas.microsoft.com/office/powerpoint/2010/main" xmlns:p15="http://schemas.microsoft.com/office/powerpoint/2012/main" xmlns:a14="http://schemas.microsoft.com/office/drawing/2010/main">
                 <a:solidFill>
                   <a:srgbClr val="FFFFFF"/>
                 </a:solidFill>
               </a14:hiddenFill>
             </a:ext>
             <a:ext uri="{91240B29-F687-4f45-9708-019B960494DF}">
-              <a14:hiddenLine xmlns:a14="http://schemas.microsoft.com/office/drawing/2010/main" xmlns:p15="http://schemas.microsoft.com/office/powerpoint/2012/main" xmlns:p14="http://schemas.microsoft.com/office/powerpoint/2010/main" xmlns:asvg="http://schemas.microsoft.com/office/drawing/2016/SVG/main" xmlns:a16="http://schemas.microsoft.com/office/drawing/2014/main" xmlns:ma14="http://schemas.microsoft.com/office/mac/drawingml/2011/main" xmlns="" w="9525">
+              <a14:hiddenLine xmlns="" xmlns:ma14="http://schemas.microsoft.com/office/mac/drawingml/2011/main" xmlns:a16="http://schemas.microsoft.com/office/drawing/2014/main" xmlns:asvg="http://schemas.microsoft.com/office/drawing/2016/SVG/main" xmlns:p14="http://schemas.microsoft.com/office/powerpoint/2010/main" xmlns:p15="http://schemas.microsoft.com/office/powerpoint/2012/main" xmlns:a14="http://schemas.microsoft.com/office/drawing/2010/main" w="9525">
                 <a:solidFill>
                   <a:srgbClr val="000000"/>
                 </a:solidFill>
@@ -7659,7 +7755,7 @@
           <a:p>
             <a:r>
               <a:rPr lang="en-US" dirty="0"/>
-              <a:t>Once the standard is created, the messages from the use case documents can be </a:t>
+              <a:t>Once the standard is created, the messages from the use case documents can be completed.</a:t>
             </a:r>
             <a:endParaRPr lang="en-CA" dirty="0"/>
           </a:p>
@@ -7889,7 +7985,7 @@
           </a:p>
           <a:p>
             <a:r>
-              <a:rPr lang="de-DE">
+              <a:rPr lang="de-DE" dirty="0">
                 <a:solidFill>
                   <a:schemeClr val="accent1"/>
                 </a:solidFill>
@@ -7897,16 +7993,8 @@
               <a:t>Sensors  </a:t>
             </a:r>
             <a:r>
-              <a:rPr lang="de-DE"/>
+              <a:rPr lang="de-DE" dirty="0"/>
               <a:t>⊑ </a:t>
-            </a:r>
-            <a:r>
-              <a:rPr lang="de-DE">
-                <a:solidFill>
-                  <a:schemeClr val="accent1"/>
-                </a:solidFill>
-              </a:rPr>
-              <a:t> </a:t>
             </a:r>
             <a:r>
               <a:rPr lang="de-DE" dirty="0">
@@ -7914,7 +8002,7 @@
                   <a:schemeClr val="accent1"/>
                 </a:solidFill>
               </a:rPr>
-              <a:t>Robot Part </a:t>
+              <a:t> Robot Part </a:t>
             </a:r>
           </a:p>
         </p:txBody>
@@ -7933,6 +8021,120 @@
 </file>
 
 <file path=ppt/slides/slide7.xml><?xml version="1.0" encoding="utf-8"?>
+<p:sld xmlns:a="http://schemas.openxmlformats.org/drawingml/2006/main" xmlns:r="http://schemas.openxmlformats.org/officeDocument/2006/relationships" xmlns:p="http://schemas.openxmlformats.org/presentationml/2006/main">
+  <p:cSld>
+    <p:spTree>
+      <p:nvGrpSpPr>
+        <p:cNvPr id="1" name=""/>
+        <p:cNvGrpSpPr/>
+        <p:nvPr/>
+      </p:nvGrpSpPr>
+      <p:grpSpPr>
+        <a:xfrm>
+          <a:off x="0" y="0"/>
+          <a:ext cx="0" cy="0"/>
+          <a:chOff x="0" y="0"/>
+          <a:chExt cx="0" cy="0"/>
+        </a:xfrm>
+      </p:grpSpPr>
+      <p:sp>
+        <p:nvSpPr>
+          <p:cNvPr id="2" name="Title 1">
+            <a:extLst>
+              <a:ext uri="{FF2B5EF4-FFF2-40B4-BE49-F238E27FC236}">
+                <a16:creationId xmlns:a16="http://schemas.microsoft.com/office/drawing/2014/main" id="{D5329235-3FBA-CD81-5496-3810E8F943A0}"/>
+              </a:ext>
+            </a:extLst>
+          </p:cNvPr>
+          <p:cNvSpPr>
+            <a:spLocks noGrp="1"/>
+          </p:cNvSpPr>
+          <p:nvPr>
+            <p:ph type="title"/>
+          </p:nvPr>
+        </p:nvSpPr>
+        <p:spPr/>
+        <p:txBody>
+          <a:bodyPr/>
+          <a:lstStyle/>
+          <a:p>
+            <a:r>
+              <a:rPr lang="en-US" dirty="0"/>
+              <a:t>Notes from meeting</a:t>
+            </a:r>
+            <a:endParaRPr lang="en-CA" dirty="0"/>
+          </a:p>
+        </p:txBody>
+      </p:sp>
+      <p:sp>
+        <p:nvSpPr>
+          <p:cNvPr id="3" name="Content Placeholder 2">
+            <a:extLst>
+              <a:ext uri="{FF2B5EF4-FFF2-40B4-BE49-F238E27FC236}">
+                <a16:creationId xmlns:a16="http://schemas.microsoft.com/office/drawing/2014/main" id="{2AD67E43-39F6-DC5C-CF93-651B23D0172D}"/>
+              </a:ext>
+            </a:extLst>
+          </p:cNvPr>
+          <p:cNvSpPr>
+            <a:spLocks noGrp="1"/>
+          </p:cNvSpPr>
+          <p:nvPr>
+            <p:ph idx="1"/>
+          </p:nvPr>
+        </p:nvSpPr>
+        <p:spPr/>
+        <p:txBody>
+          <a:bodyPr/>
+          <a:lstStyle/>
+          <a:p>
+            <a:r>
+              <a:rPr lang="en-US" dirty="0"/>
+              <a:t>To add to Use Case document:</a:t>
+            </a:r>
+          </a:p>
+          <a:p>
+            <a:pPr lvl="1"/>
+            <a:r>
+              <a:rPr lang="en-US" dirty="0"/>
+              <a:t>Use of USV to rescue downed pilots – new use case.</a:t>
+            </a:r>
+          </a:p>
+          <a:p>
+            <a:pPr lvl="1"/>
+            <a:r>
+              <a:rPr lang="en-US" dirty="0"/>
+              <a:t>Companion Drones use case.</a:t>
+            </a:r>
+          </a:p>
+          <a:p>
+            <a:r>
+              <a:rPr lang="en-US" dirty="0"/>
+              <a:t>Action Item: Elizabeth to prepare tutorial of how to capture a message.</a:t>
+            </a:r>
+          </a:p>
+          <a:p>
+            <a:r>
+              <a:rPr lang="en-US" dirty="0"/>
+              <a:t>Next meeting: Thursday, July 9.</a:t>
+            </a:r>
+            <a:endParaRPr lang="en-CA" dirty="0"/>
+          </a:p>
+        </p:txBody>
+      </p:sp>
+    </p:spTree>
+    <p:extLst>
+      <p:ext uri="{BB962C8B-B14F-4D97-AF65-F5344CB8AC3E}">
+        <p14:creationId xmlns:p14="http://schemas.microsoft.com/office/powerpoint/2010/main" val="1008458858"/>
+      </p:ext>
+    </p:extLst>
+  </p:cSld>
+  <p:clrMapOvr>
+    <a:masterClrMapping/>
+  </p:clrMapOvr>
+</p:sld>
+</file>
+
+<file path=ppt/slides/slide8.xml><?xml version="1.0" encoding="utf-8"?>
 <p:sld xmlns:a="http://schemas.openxmlformats.org/drawingml/2006/main" xmlns:r="http://schemas.openxmlformats.org/officeDocument/2006/relationships" xmlns:p="http://schemas.openxmlformats.org/presentationml/2006/main">
   <p:cSld>
     <p:bg>
@@ -9352,6 +9554,15 @@
 </file>
 
 <file path=customXml/item1.xml><?xml version="1.0" encoding="utf-8"?>
+<?mso-contentType ?>
+<FormTemplates xmlns="http://schemas.microsoft.com/sharepoint/v3/contenttype/forms">
+  <Display>DocumentLibraryForm</Display>
+  <Edit>DocumentLibraryForm</Edit>
+  <New>DocumentLibraryForm</New>
+</FormTemplates>
+</file>
+
+<file path=customXml/item2.xml><?xml version="1.0" encoding="utf-8"?>
 <ct:contentTypeSchema xmlns:ct="http://schemas.microsoft.com/office/2006/metadata/contentType" xmlns:ma="http://schemas.microsoft.com/office/2006/metadata/properties/metaAttributes" ct:_="" ma:_="" ma:contentTypeName="Document" ma:contentTypeID="0x01010027EE6BE8E9D62A489E89088165552537" ma:contentTypeVersion="23" ma:contentTypeDescription="Create a new document." ma:contentTypeScope="" ma:versionID="6e83425ab1c525ba8fce5c619b58b1dc">
   <xsd:schema xmlns:xsd="http://www.w3.org/2001/XMLSchema" xmlns:xs="http://www.w3.org/2001/XMLSchema" xmlns:p="http://schemas.microsoft.com/office/2006/metadata/properties" xmlns:ns2="9de35825-77e6-4d9d-bbc7-7a2b5e5c6d68" xmlns:ns3="12cd23af-3e52-4056-a2c9-5961a2704e29" xmlns:ns4="716d1e58-2f47-4028-a3d3-4ae2fbcdb48c" targetNamespace="http://schemas.microsoft.com/office/2006/metadata/properties" ma:root="true" ma:fieldsID="23aa16b45e4256d0f85adf32c85bedd2" ns2:_="" ns3:_="" ns4:_="">
     <xsd:import namespace="9de35825-77e6-4d9d-bbc7-7a2b5e5c6d68"/>
@@ -9611,15 +9822,6 @@
 </ct:contentTypeSchema>
 </file>
 
-<file path=customXml/item2.xml><?xml version="1.0" encoding="utf-8"?>
-<?mso-contentType ?>
-<FormTemplates xmlns="http://schemas.microsoft.com/sharepoint/v3/contenttype/forms">
-  <Display>DocumentLibraryForm</Display>
-  <Edit>DocumentLibraryForm</Edit>
-  <New>DocumentLibraryForm</New>
-</FormTemplates>
-</file>
-
 <file path=customXml/item3.xml><?xml version="1.0" encoding="utf-8"?>
 <p:properties xmlns:p="http://schemas.microsoft.com/office/2006/metadata/properties" xmlns:xsi="http://www.w3.org/2001/XMLSchema-instance" xmlns:pc="http://schemas.microsoft.com/office/infopath/2007/PartnerControls">
   <documentManagement>
@@ -9655,6 +9857,14 @@
 </file>
 
 <file path=customXml/itemProps1.xml><?xml version="1.0" encoding="utf-8"?>
+<ds:datastoreItem xmlns:ds="http://schemas.openxmlformats.org/officeDocument/2006/customXml" ds:itemID="{E37F82A6-C5BB-4E86-A9B2-E9D69C07338F}">
+  <ds:schemaRefs>
+    <ds:schemaRef ds:uri="http://schemas.microsoft.com/sharepoint/v3/contenttype/forms"/>
+  </ds:schemaRefs>
+</ds:datastoreItem>
+</file>
+
+<file path=customXml/itemProps2.xml><?xml version="1.0" encoding="utf-8"?>
 <ds:datastoreItem xmlns:ds="http://schemas.openxmlformats.org/officeDocument/2006/customXml" ds:itemID="{2CBF9799-0721-4C37-841B-72253AFD53B4}">
   <ds:schemaRefs>
     <ds:schemaRef ds:uri="http://schemas.microsoft.com/office/2006/metadata/contentType"/>
@@ -9670,14 +9880,6 @@
     <ds:schemaRef ds:uri="http://purl.org/dc/elements/1.1/"/>
     <ds:schemaRef ds:uri="http://purl.org/dc/terms/"/>
     <ds:schemaRef ds:uri="http://schemas.microsoft.com/internal/obd"/>
-  </ds:schemaRefs>
-</ds:datastoreItem>
-</file>
-
-<file path=customXml/itemProps2.xml><?xml version="1.0" encoding="utf-8"?>
-<ds:datastoreItem xmlns:ds="http://schemas.openxmlformats.org/officeDocument/2006/customXml" ds:itemID="{E37F82A6-C5BB-4E86-A9B2-E9D69C07338F}">
-  <ds:schemaRefs>
-    <ds:schemaRef ds:uri="http://schemas.microsoft.com/sharepoint/v3/contenttype/forms"/>
   </ds:schemaRefs>
 </ds:datastoreItem>
 </file>

</xml_diff>